<commit_message>
feat: website v2.0 milestone - phases 1 to 10 complete
</commit_message>
<xml_diff>
--- a/FINAL_SUBMISSION/Presentation.pptx
+++ b/FINAL_SUBMISSION/Presentation.pptx
@@ -3885,7 +3885,7 @@
         </p:nvSpPr>
         <p:spPr>
           <a:xfrm>
-            <a:off x="502920" y="1234440"/>
+            <a:off x="457200" y="1234440"/>
             <a:ext cx="11155680" cy="1828800"/>
           </a:xfrm>
           <a:prstGeom prst="rect">
@@ -4109,7 +4109,7 @@
         </p:nvSpPr>
         <p:spPr>
           <a:xfrm>
-            <a:off x="502920" y="1234440"/>
+            <a:off x="518160" y="1129441"/>
             <a:ext cx="11155680" cy="1828800"/>
           </a:xfrm>
           <a:prstGeom prst="rect">
@@ -4179,7 +4179,7 @@
         </p:blipFill>
         <p:spPr>
           <a:xfrm>
-            <a:off x="502920" y="3200400"/>
+            <a:off x="457200" y="2735779"/>
             <a:ext cx="3596640" cy="2796341"/>
           </a:xfrm>
           <a:prstGeom prst="rect">
@@ -4293,7 +4293,7 @@
         </p:blipFill>
         <p:spPr>
           <a:xfrm>
-            <a:off x="8061960" y="3200400"/>
+            <a:off x="7988808" y="2794510"/>
             <a:ext cx="3596640" cy="2678877"/>
           </a:xfrm>
           <a:prstGeom prst="rect">

</xml_diff>

<commit_message>
release: v1.0.0 final research submission and repository audit
</commit_message>
<xml_diff>
--- a/FINAL_SUBMISSION/Presentation.pptx
+++ b/FINAL_SUBMISSION/Presentation.pptx
@@ -5,32 +5,32 @@
     <p:sldMasterId id="2147483648" r:id="rId1"/>
   </p:sldMasterIdLst>
   <p:sldIdLst>
-    <p:sldId id="256" r:id="rId2"/>
-    <p:sldId id="257" r:id="rId3"/>
-    <p:sldId id="258" r:id="rId4"/>
-    <p:sldId id="259" r:id="rId5"/>
-    <p:sldId id="260" r:id="rId6"/>
-    <p:sldId id="261" r:id="rId7"/>
-    <p:sldId id="262" r:id="rId8"/>
-    <p:sldId id="263" r:id="rId9"/>
-    <p:sldId id="264" r:id="rId10"/>
-    <p:sldId id="265" r:id="rId11"/>
-    <p:sldId id="266" r:id="rId12"/>
-    <p:sldId id="267" r:id="rId13"/>
-    <p:sldId id="268" r:id="rId14"/>
-    <p:sldId id="269" r:id="rId15"/>
-    <p:sldId id="270" r:id="rId16"/>
-    <p:sldId id="271" r:id="rId17"/>
-    <p:sldId id="272" r:id="rId18"/>
-    <p:sldId id="273" r:id="rId19"/>
-    <p:sldId id="274" r:id="rId20"/>
-    <p:sldId id="275" r:id="rId21"/>
-    <p:sldId id="276" r:id="rId22"/>
-    <p:sldId id="277" r:id="rId23"/>
-    <p:sldId id="278" r:id="rId24"/>
-    <p:sldId id="279" r:id="rId25"/>
+    <p:sldId id="256" r:id="rId7"/>
+    <p:sldId id="257" r:id="rId8"/>
+    <p:sldId id="258" r:id="rId9"/>
+    <p:sldId id="259" r:id="rId10"/>
+    <p:sldId id="260" r:id="rId11"/>
+    <p:sldId id="261" r:id="rId12"/>
+    <p:sldId id="262" r:id="rId13"/>
+    <p:sldId id="263" r:id="rId14"/>
+    <p:sldId id="264" r:id="rId15"/>
+    <p:sldId id="265" r:id="rId16"/>
+    <p:sldId id="266" r:id="rId17"/>
+    <p:sldId id="267" r:id="rId18"/>
+    <p:sldId id="268" r:id="rId19"/>
+    <p:sldId id="269" r:id="rId20"/>
+    <p:sldId id="270" r:id="rId21"/>
+    <p:sldId id="271" r:id="rId22"/>
+    <p:sldId id="272" r:id="rId23"/>
+    <p:sldId id="273" r:id="rId24"/>
+    <p:sldId id="274" r:id="rId25"/>
+    <p:sldId id="275" r:id="rId26"/>
+    <p:sldId id="276" r:id="rId27"/>
+    <p:sldId id="277" r:id="rId28"/>
+    <p:sldId id="278" r:id="rId29"/>
+    <p:sldId id="279" r:id="rId30"/>
   </p:sldIdLst>
-  <p:sldSz cx="12192000" cy="6858000"/>
+  <p:sldSz cx="12191695" cy="6858000" type="screen4x3"/>
   <p:notesSz cx="6858000" cy="9144000"/>
   <p:defaultTextStyle>
     <a:defPPr>
@@ -127,22 +127,6 @@
       </a:defRPr>
     </a:lvl9pPr>
   </p:defaultTextStyle>
-  <p:extLst>
-    <p:ext uri="{EFAFB233-063F-42B5-8137-9DF3F51BA10A}">
-      <p15:sldGuideLst xmlns:p15="http://schemas.microsoft.com/office/powerpoint/2012/main">
-        <p15:guide id="1" orient="horz" pos="2160">
-          <p15:clr>
-            <a:srgbClr val="A4A3A4"/>
-          </p15:clr>
-        </p15:guide>
-        <p15:guide id="2" pos="2880">
-          <p15:clr>
-            <a:srgbClr val="A4A3A4"/>
-          </p15:clr>
-        </p15:guide>
-      </p15:sldGuideLst>
-    </p:ext>
-  </p:extLst>
 </p:presentation>
 </file>
 
@@ -184,9 +168,10 @@
           <a:lstStyle/>
           <a:p>
             <a:r>
-              <a:rPr lang="en-US"/>
+              <a:rPr lang="en-US" smtClean="0"/>
               <a:t>Click to edit Master title style</a:t>
             </a:r>
+            <a:endParaRPr lang="en-US"/>
           </a:p>
         </p:txBody>
       </p:sp>
@@ -302,9 +287,10 @@
           </a:lstStyle>
           <a:p>
             <a:r>
-              <a:rPr lang="en-US"/>
+              <a:rPr lang="en-US" smtClean="0"/>
               <a:t>Click to edit Master subtitle style</a:t>
             </a:r>
+            <a:endParaRPr lang="en-US"/>
           </a:p>
         </p:txBody>
       </p:sp>
@@ -325,7 +311,7 @@
           <a:p>
             <a:fld id="{5BCAD085-E8A6-8845-BD4E-CB4CCA059FC4}" type="datetimeFigureOut">
               <a:rPr lang="en-US" smtClean="0"/>
-              <a:t>7/29/2026</a:t>
+              <a:t>1/27/13</a:t>
             </a:fld>
             <a:endParaRPr lang="en-US"/>
           </a:p>
@@ -419,9 +405,10 @@
           <a:lstStyle/>
           <a:p>
             <a:r>
-              <a:rPr lang="en-US"/>
+              <a:rPr lang="en-US" smtClean="0"/>
               <a:t>Click to edit Master title style</a:t>
             </a:r>
+            <a:endParaRPr lang="en-US"/>
           </a:p>
         </p:txBody>
       </p:sp>
@@ -442,37 +429,38 @@
           <a:p>
             <a:pPr lvl="0"/>
             <a:r>
-              <a:rPr lang="en-US"/>
+              <a:rPr lang="en-US" smtClean="0"/>
               <a:t>Click to edit Master text styles</a:t>
             </a:r>
           </a:p>
           <a:p>
             <a:pPr lvl="1"/>
             <a:r>
-              <a:rPr lang="en-US"/>
+              <a:rPr lang="en-US" smtClean="0"/>
               <a:t>Second level</a:t>
             </a:r>
           </a:p>
           <a:p>
             <a:pPr lvl="2"/>
             <a:r>
-              <a:rPr lang="en-US"/>
+              <a:rPr lang="en-US" smtClean="0"/>
               <a:t>Third level</a:t>
             </a:r>
           </a:p>
           <a:p>
             <a:pPr lvl="3"/>
             <a:r>
-              <a:rPr lang="en-US"/>
+              <a:rPr lang="en-US" smtClean="0"/>
               <a:t>Fourth level</a:t>
             </a:r>
           </a:p>
           <a:p>
             <a:pPr lvl="4"/>
             <a:r>
-              <a:rPr lang="en-US"/>
+              <a:rPr lang="en-US" smtClean="0"/>
               <a:t>Fifth level</a:t>
             </a:r>
+            <a:endParaRPr lang="en-US"/>
           </a:p>
         </p:txBody>
       </p:sp>
@@ -493,7 +481,7 @@
           <a:p>
             <a:fld id="{5BCAD085-E8A6-8845-BD4E-CB4CCA059FC4}" type="datetimeFigureOut">
               <a:rPr lang="en-US" smtClean="0"/>
-              <a:t>7/29/2026</a:t>
+              <a:t>1/27/13</a:t>
             </a:fld>
             <a:endParaRPr lang="en-US"/>
           </a:p>
@@ -592,9 +580,10 @@
           <a:lstStyle/>
           <a:p>
             <a:r>
-              <a:rPr lang="en-US"/>
+              <a:rPr lang="en-US" smtClean="0"/>
               <a:t>Click to edit Master title style</a:t>
             </a:r>
+            <a:endParaRPr lang="en-US"/>
           </a:p>
         </p:txBody>
       </p:sp>
@@ -620,37 +609,38 @@
           <a:p>
             <a:pPr lvl="0"/>
             <a:r>
-              <a:rPr lang="en-US"/>
+              <a:rPr lang="en-US" smtClean="0"/>
               <a:t>Click to edit Master text styles</a:t>
             </a:r>
           </a:p>
           <a:p>
             <a:pPr lvl="1"/>
             <a:r>
-              <a:rPr lang="en-US"/>
+              <a:rPr lang="en-US" smtClean="0"/>
               <a:t>Second level</a:t>
             </a:r>
           </a:p>
           <a:p>
             <a:pPr lvl="2"/>
             <a:r>
-              <a:rPr lang="en-US"/>
+              <a:rPr lang="en-US" smtClean="0"/>
               <a:t>Third level</a:t>
             </a:r>
           </a:p>
           <a:p>
             <a:pPr lvl="3"/>
             <a:r>
-              <a:rPr lang="en-US"/>
+              <a:rPr lang="en-US" smtClean="0"/>
               <a:t>Fourth level</a:t>
             </a:r>
           </a:p>
           <a:p>
             <a:pPr lvl="4"/>
             <a:r>
-              <a:rPr lang="en-US"/>
+              <a:rPr lang="en-US" smtClean="0"/>
               <a:t>Fifth level</a:t>
             </a:r>
+            <a:endParaRPr lang="en-US"/>
           </a:p>
         </p:txBody>
       </p:sp>
@@ -671,7 +661,7 @@
           <a:p>
             <a:fld id="{5BCAD085-E8A6-8845-BD4E-CB4CCA059FC4}" type="datetimeFigureOut">
               <a:rPr lang="en-US" smtClean="0"/>
-              <a:t>7/29/2026</a:t>
+              <a:t>1/27/13</a:t>
             </a:fld>
             <a:endParaRPr lang="en-US"/>
           </a:p>
@@ -765,9 +755,10 @@
           <a:lstStyle/>
           <a:p>
             <a:r>
-              <a:rPr lang="en-US"/>
+              <a:rPr lang="en-US" smtClean="0"/>
               <a:t>Click to edit Master title style</a:t>
             </a:r>
+            <a:endParaRPr lang="en-US"/>
           </a:p>
         </p:txBody>
       </p:sp>
@@ -788,37 +779,38 @@
           <a:p>
             <a:pPr lvl="0"/>
             <a:r>
-              <a:rPr lang="en-US"/>
+              <a:rPr lang="en-US" smtClean="0"/>
               <a:t>Click to edit Master text styles</a:t>
             </a:r>
           </a:p>
           <a:p>
             <a:pPr lvl="1"/>
             <a:r>
-              <a:rPr lang="en-US"/>
+              <a:rPr lang="en-US" smtClean="0"/>
               <a:t>Second level</a:t>
             </a:r>
           </a:p>
           <a:p>
             <a:pPr lvl="2"/>
             <a:r>
-              <a:rPr lang="en-US"/>
+              <a:rPr lang="en-US" smtClean="0"/>
               <a:t>Third level</a:t>
             </a:r>
           </a:p>
           <a:p>
             <a:pPr lvl="3"/>
             <a:r>
-              <a:rPr lang="en-US"/>
+              <a:rPr lang="en-US" smtClean="0"/>
               <a:t>Fourth level</a:t>
             </a:r>
           </a:p>
           <a:p>
             <a:pPr lvl="4"/>
             <a:r>
-              <a:rPr lang="en-US"/>
+              <a:rPr lang="en-US" smtClean="0"/>
               <a:t>Fifth level</a:t>
             </a:r>
+            <a:endParaRPr lang="en-US"/>
           </a:p>
         </p:txBody>
       </p:sp>
@@ -839,7 +831,7 @@
           <a:p>
             <a:fld id="{5BCAD085-E8A6-8845-BD4E-CB4CCA059FC4}" type="datetimeFigureOut">
               <a:rPr lang="en-US" smtClean="0"/>
-              <a:t>7/29/2026</a:t>
+              <a:t>1/27/13</a:t>
             </a:fld>
             <a:endParaRPr lang="en-US"/>
           </a:p>
@@ -942,9 +934,10 @@
           </a:lstStyle>
           <a:p>
             <a:r>
-              <a:rPr lang="en-US"/>
+              <a:rPr lang="en-US" smtClean="0"/>
               <a:t>Click to edit Master title style</a:t>
             </a:r>
+            <a:endParaRPr lang="en-US"/>
           </a:p>
         </p:txBody>
       </p:sp>
@@ -1061,7 +1054,7 @@
           <a:p>
             <a:pPr lvl="0"/>
             <a:r>
-              <a:rPr lang="en-US"/>
+              <a:rPr lang="en-US" smtClean="0"/>
               <a:t>Click to edit Master text styles</a:t>
             </a:r>
           </a:p>
@@ -1084,7 +1077,7 @@
           <a:p>
             <a:fld id="{5BCAD085-E8A6-8845-BD4E-CB4CCA059FC4}" type="datetimeFigureOut">
               <a:rPr lang="en-US" smtClean="0"/>
-              <a:t>7/29/2026</a:t>
+              <a:t>1/27/13</a:t>
             </a:fld>
             <a:endParaRPr lang="en-US"/>
           </a:p>
@@ -1178,9 +1171,10 @@
           <a:lstStyle/>
           <a:p>
             <a:r>
-              <a:rPr lang="en-US"/>
+              <a:rPr lang="en-US" smtClean="0"/>
               <a:t>Click to edit Master title style</a:t>
             </a:r>
+            <a:endParaRPr lang="en-US"/>
           </a:p>
         </p:txBody>
       </p:sp>
@@ -1234,37 +1228,38 @@
           <a:p>
             <a:pPr lvl="0"/>
             <a:r>
-              <a:rPr lang="en-US"/>
+              <a:rPr lang="en-US" smtClean="0"/>
               <a:t>Click to edit Master text styles</a:t>
             </a:r>
           </a:p>
           <a:p>
             <a:pPr lvl="1"/>
             <a:r>
-              <a:rPr lang="en-US"/>
+              <a:rPr lang="en-US" smtClean="0"/>
               <a:t>Second level</a:t>
             </a:r>
           </a:p>
           <a:p>
             <a:pPr lvl="2"/>
             <a:r>
-              <a:rPr lang="en-US"/>
+              <a:rPr lang="en-US" smtClean="0"/>
               <a:t>Third level</a:t>
             </a:r>
           </a:p>
           <a:p>
             <a:pPr lvl="3"/>
             <a:r>
-              <a:rPr lang="en-US"/>
+              <a:rPr lang="en-US" smtClean="0"/>
               <a:t>Fourth level</a:t>
             </a:r>
           </a:p>
           <a:p>
             <a:pPr lvl="4"/>
             <a:r>
-              <a:rPr lang="en-US"/>
+              <a:rPr lang="en-US" smtClean="0"/>
               <a:t>Fifth level</a:t>
             </a:r>
+            <a:endParaRPr lang="en-US"/>
           </a:p>
         </p:txBody>
       </p:sp>
@@ -1318,37 +1313,38 @@
           <a:p>
             <a:pPr lvl="0"/>
             <a:r>
-              <a:rPr lang="en-US"/>
+              <a:rPr lang="en-US" smtClean="0"/>
               <a:t>Click to edit Master text styles</a:t>
             </a:r>
           </a:p>
           <a:p>
             <a:pPr lvl="1"/>
             <a:r>
-              <a:rPr lang="en-US"/>
+              <a:rPr lang="en-US" smtClean="0"/>
               <a:t>Second level</a:t>
             </a:r>
           </a:p>
           <a:p>
             <a:pPr lvl="2"/>
             <a:r>
-              <a:rPr lang="en-US"/>
+              <a:rPr lang="en-US" smtClean="0"/>
               <a:t>Third level</a:t>
             </a:r>
           </a:p>
           <a:p>
             <a:pPr lvl="3"/>
             <a:r>
-              <a:rPr lang="en-US"/>
+              <a:rPr lang="en-US" smtClean="0"/>
               <a:t>Fourth level</a:t>
             </a:r>
           </a:p>
           <a:p>
             <a:pPr lvl="4"/>
             <a:r>
-              <a:rPr lang="en-US"/>
+              <a:rPr lang="en-US" smtClean="0"/>
               <a:t>Fifth level</a:t>
             </a:r>
+            <a:endParaRPr lang="en-US"/>
           </a:p>
         </p:txBody>
       </p:sp>
@@ -1369,7 +1365,7 @@
           <a:p>
             <a:fld id="{5BCAD085-E8A6-8845-BD4E-CB4CCA059FC4}" type="datetimeFigureOut">
               <a:rPr lang="en-US" smtClean="0"/>
-              <a:t>7/29/2026</a:t>
+              <a:t>1/27/13</a:t>
             </a:fld>
             <a:endParaRPr lang="en-US"/>
           </a:p>
@@ -1467,9 +1463,10 @@
           </a:lstStyle>
           <a:p>
             <a:r>
-              <a:rPr lang="en-US"/>
+              <a:rPr lang="en-US" smtClean="0"/>
               <a:t>Click to edit Master title style</a:t>
             </a:r>
+            <a:endParaRPr lang="en-US"/>
           </a:p>
         </p:txBody>
       </p:sp>
@@ -1532,7 +1529,7 @@
           <a:p>
             <a:pPr lvl="0"/>
             <a:r>
-              <a:rPr lang="en-US"/>
+              <a:rPr lang="en-US" smtClean="0"/>
               <a:t>Click to edit Master text styles</a:t>
             </a:r>
           </a:p>
@@ -1588,37 +1585,38 @@
           <a:p>
             <a:pPr lvl="0"/>
             <a:r>
-              <a:rPr lang="en-US"/>
+              <a:rPr lang="en-US" smtClean="0"/>
               <a:t>Click to edit Master text styles</a:t>
             </a:r>
           </a:p>
           <a:p>
             <a:pPr lvl="1"/>
             <a:r>
-              <a:rPr lang="en-US"/>
+              <a:rPr lang="en-US" smtClean="0"/>
               <a:t>Second level</a:t>
             </a:r>
           </a:p>
           <a:p>
             <a:pPr lvl="2"/>
             <a:r>
-              <a:rPr lang="en-US"/>
+              <a:rPr lang="en-US" smtClean="0"/>
               <a:t>Third level</a:t>
             </a:r>
           </a:p>
           <a:p>
             <a:pPr lvl="3"/>
             <a:r>
-              <a:rPr lang="en-US"/>
+              <a:rPr lang="en-US" smtClean="0"/>
               <a:t>Fourth level</a:t>
             </a:r>
           </a:p>
           <a:p>
             <a:pPr lvl="4"/>
             <a:r>
-              <a:rPr lang="en-US"/>
+              <a:rPr lang="en-US" smtClean="0"/>
               <a:t>Fifth level</a:t>
             </a:r>
+            <a:endParaRPr lang="en-US"/>
           </a:p>
         </p:txBody>
       </p:sp>
@@ -1681,7 +1679,7 @@
           <a:p>
             <a:pPr lvl="0"/>
             <a:r>
-              <a:rPr lang="en-US"/>
+              <a:rPr lang="en-US" smtClean="0"/>
               <a:t>Click to edit Master text styles</a:t>
             </a:r>
           </a:p>
@@ -1737,37 +1735,38 @@
           <a:p>
             <a:pPr lvl="0"/>
             <a:r>
-              <a:rPr lang="en-US"/>
+              <a:rPr lang="en-US" smtClean="0"/>
               <a:t>Click to edit Master text styles</a:t>
             </a:r>
           </a:p>
           <a:p>
             <a:pPr lvl="1"/>
             <a:r>
-              <a:rPr lang="en-US"/>
+              <a:rPr lang="en-US" smtClean="0"/>
               <a:t>Second level</a:t>
             </a:r>
           </a:p>
           <a:p>
             <a:pPr lvl="2"/>
             <a:r>
-              <a:rPr lang="en-US"/>
+              <a:rPr lang="en-US" smtClean="0"/>
               <a:t>Third level</a:t>
             </a:r>
           </a:p>
           <a:p>
             <a:pPr lvl="3"/>
             <a:r>
-              <a:rPr lang="en-US"/>
+              <a:rPr lang="en-US" smtClean="0"/>
               <a:t>Fourth level</a:t>
             </a:r>
           </a:p>
           <a:p>
             <a:pPr lvl="4"/>
             <a:r>
-              <a:rPr lang="en-US"/>
+              <a:rPr lang="en-US" smtClean="0"/>
               <a:t>Fifth level</a:t>
             </a:r>
+            <a:endParaRPr lang="en-US"/>
           </a:p>
         </p:txBody>
       </p:sp>
@@ -1788,7 +1787,7 @@
           <a:p>
             <a:fld id="{5BCAD085-E8A6-8845-BD4E-CB4CCA059FC4}" type="datetimeFigureOut">
               <a:rPr lang="en-US" smtClean="0"/>
-              <a:t>7/29/2026</a:t>
+              <a:t>1/27/13</a:t>
             </a:fld>
             <a:endParaRPr lang="en-US"/>
           </a:p>
@@ -1882,9 +1881,10 @@
           <a:lstStyle/>
           <a:p>
             <a:r>
-              <a:rPr lang="en-US"/>
+              <a:rPr lang="en-US" smtClean="0"/>
               <a:t>Click to edit Master title style</a:t>
             </a:r>
+            <a:endParaRPr lang="en-US"/>
           </a:p>
         </p:txBody>
       </p:sp>
@@ -1905,7 +1905,7 @@
           <a:p>
             <a:fld id="{5BCAD085-E8A6-8845-BD4E-CB4CCA059FC4}" type="datetimeFigureOut">
               <a:rPr lang="en-US" smtClean="0"/>
-              <a:t>7/29/2026</a:t>
+              <a:t>1/27/13</a:t>
             </a:fld>
             <a:endParaRPr lang="en-US"/>
           </a:p>
@@ -2000,7 +2000,7 @@
           <a:p>
             <a:fld id="{5BCAD085-E8A6-8845-BD4E-CB4CCA059FC4}" type="datetimeFigureOut">
               <a:rPr lang="en-US" smtClean="0"/>
-              <a:t>7/29/2026</a:t>
+              <a:t>1/27/13</a:t>
             </a:fld>
             <a:endParaRPr lang="en-US"/>
           </a:p>
@@ -2103,9 +2103,10 @@
           </a:lstStyle>
           <a:p>
             <a:r>
-              <a:rPr lang="en-US"/>
+              <a:rPr lang="en-US" smtClean="0"/>
               <a:t>Click to edit Master title style</a:t>
             </a:r>
+            <a:endParaRPr lang="en-US"/>
           </a:p>
         </p:txBody>
       </p:sp>
@@ -2159,37 +2160,38 @@
           <a:p>
             <a:pPr lvl="0"/>
             <a:r>
-              <a:rPr lang="en-US"/>
+              <a:rPr lang="en-US" smtClean="0"/>
               <a:t>Click to edit Master text styles</a:t>
             </a:r>
           </a:p>
           <a:p>
             <a:pPr lvl="1"/>
             <a:r>
-              <a:rPr lang="en-US"/>
+              <a:rPr lang="en-US" smtClean="0"/>
               <a:t>Second level</a:t>
             </a:r>
           </a:p>
           <a:p>
             <a:pPr lvl="2"/>
             <a:r>
-              <a:rPr lang="en-US"/>
+              <a:rPr lang="en-US" smtClean="0"/>
               <a:t>Third level</a:t>
             </a:r>
           </a:p>
           <a:p>
             <a:pPr lvl="3"/>
             <a:r>
-              <a:rPr lang="en-US"/>
+              <a:rPr lang="en-US" smtClean="0"/>
               <a:t>Fourth level</a:t>
             </a:r>
           </a:p>
           <a:p>
             <a:pPr lvl="4"/>
             <a:r>
-              <a:rPr lang="en-US"/>
+              <a:rPr lang="en-US" smtClean="0"/>
               <a:t>Fifth level</a:t>
             </a:r>
+            <a:endParaRPr lang="en-US"/>
           </a:p>
         </p:txBody>
       </p:sp>
@@ -2252,7 +2254,7 @@
           <a:p>
             <a:pPr lvl="0"/>
             <a:r>
-              <a:rPr lang="en-US"/>
+              <a:rPr lang="en-US" smtClean="0"/>
               <a:t>Click to edit Master text styles</a:t>
             </a:r>
           </a:p>
@@ -2275,7 +2277,7 @@
           <a:p>
             <a:fld id="{5BCAD085-E8A6-8845-BD4E-CB4CCA059FC4}" type="datetimeFigureOut">
               <a:rPr lang="en-US" smtClean="0"/>
-              <a:t>7/29/2026</a:t>
+              <a:t>1/27/13</a:t>
             </a:fld>
             <a:endParaRPr lang="en-US"/>
           </a:p>
@@ -2378,9 +2380,10 @@
           </a:lstStyle>
           <a:p>
             <a:r>
-              <a:rPr lang="en-US"/>
+              <a:rPr lang="en-US" smtClean="0"/>
               <a:t>Click to edit Master title style</a:t>
             </a:r>
+            <a:endParaRPr lang="en-US"/>
           </a:p>
         </p:txBody>
       </p:sp>
@@ -2504,7 +2507,7 @@
           <a:p>
             <a:pPr lvl="0"/>
             <a:r>
-              <a:rPr lang="en-US"/>
+              <a:rPr lang="en-US" smtClean="0"/>
               <a:t>Click to edit Master text styles</a:t>
             </a:r>
           </a:p>
@@ -2527,7 +2530,7 @@
           <a:p>
             <a:fld id="{5BCAD085-E8A6-8845-BD4E-CB4CCA059FC4}" type="datetimeFigureOut">
               <a:rPr lang="en-US" smtClean="0"/>
-              <a:t>7/29/2026</a:t>
+              <a:t>1/27/13</a:t>
             </a:fld>
             <a:endParaRPr lang="en-US"/>
           </a:p>
@@ -2636,9 +2639,10 @@
           <a:lstStyle/>
           <a:p>
             <a:r>
-              <a:rPr lang="en-US"/>
+              <a:rPr lang="en-US" smtClean="0"/>
               <a:t>Click to edit Master title style</a:t>
             </a:r>
+            <a:endParaRPr lang="en-US"/>
           </a:p>
         </p:txBody>
       </p:sp>
@@ -2669,37 +2673,38 @@
           <a:p>
             <a:pPr lvl="0"/>
             <a:r>
-              <a:rPr lang="en-US"/>
+              <a:rPr lang="en-US" smtClean="0"/>
               <a:t>Click to edit Master text styles</a:t>
             </a:r>
           </a:p>
           <a:p>
             <a:pPr lvl="1"/>
             <a:r>
-              <a:rPr lang="en-US"/>
+              <a:rPr lang="en-US" smtClean="0"/>
               <a:t>Second level</a:t>
             </a:r>
           </a:p>
           <a:p>
             <a:pPr lvl="2"/>
             <a:r>
-              <a:rPr lang="en-US"/>
+              <a:rPr lang="en-US" smtClean="0"/>
               <a:t>Third level</a:t>
             </a:r>
           </a:p>
           <a:p>
             <a:pPr lvl="3"/>
             <a:r>
-              <a:rPr lang="en-US"/>
+              <a:rPr lang="en-US" smtClean="0"/>
               <a:t>Fourth level</a:t>
             </a:r>
           </a:p>
           <a:p>
             <a:pPr lvl="4"/>
             <a:r>
-              <a:rPr lang="en-US"/>
+              <a:rPr lang="en-US" smtClean="0"/>
               <a:t>Fifth level</a:t>
             </a:r>
+            <a:endParaRPr lang="en-US"/>
           </a:p>
         </p:txBody>
       </p:sp>
@@ -2738,7 +2743,7 @@
           <a:p>
             <a:fld id="{5BCAD085-E8A6-8845-BD4E-CB4CCA059FC4}" type="datetimeFigureOut">
               <a:rPr lang="en-US" smtClean="0"/>
-              <a:t>7/29/2026</a:t>
+              <a:t>1/27/13</a:t>
             </a:fld>
             <a:endParaRPr lang="en-US"/>
           </a:p>
@@ -3097,7 +3102,7 @@
 </file>
 
 <file path=ppt/slides/slide1.xml><?xml version="1.0" encoding="utf-8"?>
-<p:sld xmlns:a="http://schemas.openxmlformats.org/drawingml/2006/main" xmlns:r="http://schemas.openxmlformats.org/officeDocument/2006/relationships" xmlns:p="http://schemas.openxmlformats.org/presentationml/2006/main">
+<p:sld xmlns:a="http://schemas.openxmlformats.org/drawingml/2006/main" xmlns:p="http://schemas.openxmlformats.org/presentationml/2006/main" xmlns:r="http://schemas.openxmlformats.org/officeDocument/2006/relationships">
   <p:cSld>
     <p:bg>
       <p:bgPr>
@@ -3113,14 +3118,7 @@
         <p:cNvGrpSpPr/>
         <p:nvPr/>
       </p:nvGrpSpPr>
-      <p:grpSpPr>
-        <a:xfrm>
-          <a:off x="0" y="0"/>
-          <a:ext cx="0" cy="0"/>
-          <a:chOff x="0" y="0"/>
-          <a:chExt cx="0" cy="0"/>
-        </a:xfrm>
-      </p:grpSpPr>
+      <p:grpSpPr/>
       <p:sp>
         <p:nvSpPr>
           <p:cNvPr id="2" name="TextBox 1"/>
@@ -3277,7 +3275,7 @@
 </file>
 
 <file path=ppt/slides/slide10.xml><?xml version="1.0" encoding="utf-8"?>
-<p:sld xmlns:a="http://schemas.openxmlformats.org/drawingml/2006/main" xmlns:r="http://schemas.openxmlformats.org/officeDocument/2006/relationships" xmlns:p="http://schemas.openxmlformats.org/presentationml/2006/main">
+<p:sld xmlns:a="http://schemas.openxmlformats.org/drawingml/2006/main" xmlns:p="http://schemas.openxmlformats.org/presentationml/2006/main" xmlns:r="http://schemas.openxmlformats.org/officeDocument/2006/relationships">
   <p:cSld>
     <p:bg>
       <p:bgPr>
@@ -3293,14 +3291,7 @@
         <p:cNvGrpSpPr/>
         <p:nvPr/>
       </p:nvGrpSpPr>
-      <p:grpSpPr>
-        <a:xfrm>
-          <a:off x="0" y="0"/>
-          <a:ext cx="0" cy="0"/>
-          <a:chOff x="0" y="0"/>
-          <a:chExt cx="0" cy="0"/>
-        </a:xfrm>
-      </p:grpSpPr>
+      <p:grpSpPr/>
       <p:sp>
         <p:nvSpPr>
           <p:cNvPr id="2" name="TextBox 1"/>
@@ -3457,7 +3448,7 @@
 </file>
 
 <file path=ppt/slides/slide11.xml><?xml version="1.0" encoding="utf-8"?>
-<p:sld xmlns:a="http://schemas.openxmlformats.org/drawingml/2006/main" xmlns:r="http://schemas.openxmlformats.org/officeDocument/2006/relationships" xmlns:p="http://schemas.openxmlformats.org/presentationml/2006/main">
+<p:sld xmlns:a="http://schemas.openxmlformats.org/drawingml/2006/main" xmlns:p="http://schemas.openxmlformats.org/presentationml/2006/main" xmlns:r="http://schemas.openxmlformats.org/officeDocument/2006/relationships">
   <p:cSld>
     <p:bg>
       <p:bgPr>
@@ -3473,14 +3464,7 @@
         <p:cNvGrpSpPr/>
         <p:nvPr/>
       </p:nvGrpSpPr>
-      <p:grpSpPr>
-        <a:xfrm>
-          <a:off x="0" y="0"/>
-          <a:ext cx="0" cy="0"/>
-          <a:chOff x="0" y="0"/>
-          <a:chExt cx="0" cy="0"/>
-        </a:xfrm>
-      </p:grpSpPr>
+      <p:grpSpPr/>
       <p:sp>
         <p:nvSpPr>
           <p:cNvPr id="2" name="TextBox 1"/>
@@ -3637,7 +3621,7 @@
 </file>
 
 <file path=ppt/slides/slide12.xml><?xml version="1.0" encoding="utf-8"?>
-<p:sld xmlns:a="http://schemas.openxmlformats.org/drawingml/2006/main" xmlns:r="http://schemas.openxmlformats.org/officeDocument/2006/relationships" xmlns:p="http://schemas.openxmlformats.org/presentationml/2006/main">
+<p:sld xmlns:a="http://schemas.openxmlformats.org/drawingml/2006/main" xmlns:p="http://schemas.openxmlformats.org/presentationml/2006/main" xmlns:r="http://schemas.openxmlformats.org/officeDocument/2006/relationships">
   <p:cSld>
     <p:bg>
       <p:bgPr>
@@ -3653,14 +3637,7 @@
         <p:cNvGrpSpPr/>
         <p:nvPr/>
       </p:nvGrpSpPr>
-      <p:grpSpPr>
-        <a:xfrm>
-          <a:off x="0" y="0"/>
-          <a:ext cx="0" cy="0"/>
-          <a:chOff x="0" y="0"/>
-          <a:chExt cx="0" cy="0"/>
-        </a:xfrm>
-      </p:grpSpPr>
+      <p:grpSpPr/>
       <p:sp>
         <p:nvSpPr>
           <p:cNvPr id="2" name="TextBox 1"/>
@@ -3817,7 +3794,7 @@
 </file>
 
 <file path=ppt/slides/slide13.xml><?xml version="1.0" encoding="utf-8"?>
-<p:sld xmlns:a="http://schemas.openxmlformats.org/drawingml/2006/main" xmlns:r="http://schemas.openxmlformats.org/officeDocument/2006/relationships" xmlns:p="http://schemas.openxmlformats.org/presentationml/2006/main">
+<p:sld xmlns:a="http://schemas.openxmlformats.org/drawingml/2006/main" xmlns:p="http://schemas.openxmlformats.org/presentationml/2006/main" xmlns:r="http://schemas.openxmlformats.org/officeDocument/2006/relationships">
   <p:cSld>
     <p:bg>
       <p:bgPr>
@@ -3833,14 +3810,7 @@
         <p:cNvGrpSpPr/>
         <p:nvPr/>
       </p:nvGrpSpPr>
-      <p:grpSpPr>
-        <a:xfrm>
-          <a:off x="0" y="0"/>
-          <a:ext cx="0" cy="0"/>
-          <a:chOff x="0" y="0"/>
-          <a:chExt cx="0" cy="0"/>
-        </a:xfrm>
-      </p:grpSpPr>
+      <p:grpSpPr/>
       <p:sp>
         <p:nvSpPr>
           <p:cNvPr id="2" name="TextBox 1"/>
@@ -3885,7 +3855,7 @@
         </p:nvSpPr>
         <p:spPr>
           <a:xfrm>
-            <a:off x="457200" y="1234440"/>
+            <a:off x="502920" y="1234440"/>
             <a:ext cx="11155680" cy="1828800"/>
           </a:xfrm>
           <a:prstGeom prst="rect">
@@ -3955,8 +3925,8 @@
         </p:blipFill>
         <p:spPr>
           <a:xfrm>
-            <a:off x="1938528" y="2376062"/>
-            <a:ext cx="7781544" cy="3944070"/>
+            <a:off x="502920" y="3200400"/>
+            <a:ext cx="11155680" cy="5654249"/>
           </a:xfrm>
           <a:prstGeom prst="rect">
             <a:avLst/>
@@ -4041,7 +4011,7 @@
 </file>
 
 <file path=ppt/slides/slide14.xml><?xml version="1.0" encoding="utf-8"?>
-<p:sld xmlns:a="http://schemas.openxmlformats.org/drawingml/2006/main" xmlns:r="http://schemas.openxmlformats.org/officeDocument/2006/relationships" xmlns:p="http://schemas.openxmlformats.org/presentationml/2006/main">
+<p:sld xmlns:a="http://schemas.openxmlformats.org/drawingml/2006/main" xmlns:p="http://schemas.openxmlformats.org/presentationml/2006/main" xmlns:r="http://schemas.openxmlformats.org/officeDocument/2006/relationships">
   <p:cSld>
     <p:bg>
       <p:bgPr>
@@ -4057,14 +4027,7 @@
         <p:cNvGrpSpPr/>
         <p:nvPr/>
       </p:nvGrpSpPr>
-      <p:grpSpPr>
-        <a:xfrm>
-          <a:off x="0" y="0"/>
-          <a:ext cx="0" cy="0"/>
-          <a:chOff x="0" y="0"/>
-          <a:chExt cx="0" cy="0"/>
-        </a:xfrm>
-      </p:grpSpPr>
+      <p:grpSpPr/>
       <p:sp>
         <p:nvSpPr>
           <p:cNvPr id="2" name="TextBox 1"/>
@@ -4109,7 +4072,7 @@
         </p:nvSpPr>
         <p:spPr>
           <a:xfrm>
-            <a:off x="518160" y="1129441"/>
+            <a:off x="502920" y="1234440"/>
             <a:ext cx="11155680" cy="1828800"/>
           </a:xfrm>
           <a:prstGeom prst="rect">
@@ -4179,7 +4142,7 @@
         </p:blipFill>
         <p:spPr>
           <a:xfrm>
-            <a:off x="457200" y="2735779"/>
+            <a:off x="502920" y="3200400"/>
             <a:ext cx="3596640" cy="2796341"/>
           </a:xfrm>
           <a:prstGeom prst="rect">
@@ -4293,7 +4256,7 @@
         </p:blipFill>
         <p:spPr>
           <a:xfrm>
-            <a:off x="7988808" y="2794510"/>
+            <a:off x="8061960" y="3200400"/>
             <a:ext cx="3596640" cy="2678877"/>
           </a:xfrm>
           <a:prstGeom prst="rect">
@@ -4379,7 +4342,7 @@
 </file>
 
 <file path=ppt/slides/slide15.xml><?xml version="1.0" encoding="utf-8"?>
-<p:sld xmlns:a="http://schemas.openxmlformats.org/drawingml/2006/main" xmlns:r="http://schemas.openxmlformats.org/officeDocument/2006/relationships" xmlns:p="http://schemas.openxmlformats.org/presentationml/2006/main">
+<p:sld xmlns:a="http://schemas.openxmlformats.org/drawingml/2006/main" xmlns:p="http://schemas.openxmlformats.org/presentationml/2006/main" xmlns:r="http://schemas.openxmlformats.org/officeDocument/2006/relationships">
   <p:cSld>
     <p:bg>
       <p:bgPr>
@@ -4395,14 +4358,7 @@
         <p:cNvGrpSpPr/>
         <p:nvPr/>
       </p:nvGrpSpPr>
-      <p:grpSpPr>
-        <a:xfrm>
-          <a:off x="0" y="0"/>
-          <a:ext cx="0" cy="0"/>
-          <a:chOff x="0" y="0"/>
-          <a:chExt cx="0" cy="0"/>
-        </a:xfrm>
-      </p:grpSpPr>
+      <p:grpSpPr/>
       <p:sp>
         <p:nvSpPr>
           <p:cNvPr id="2" name="TextBox 1"/>
@@ -4517,8 +4473,8 @@
         </p:blipFill>
         <p:spPr>
           <a:xfrm>
-            <a:off x="5917822" y="850392"/>
-            <a:ext cx="5408995" cy="5473846"/>
+            <a:off x="502920" y="3200400"/>
+            <a:ext cx="11155680" cy="11289431"/>
           </a:xfrm>
           <a:prstGeom prst="rect">
             <a:avLst/>
@@ -4603,7 +4559,7 @@
 </file>
 
 <file path=ppt/slides/slide16.xml><?xml version="1.0" encoding="utf-8"?>
-<p:sld xmlns:a="http://schemas.openxmlformats.org/drawingml/2006/main" xmlns:r="http://schemas.openxmlformats.org/officeDocument/2006/relationships" xmlns:p="http://schemas.openxmlformats.org/presentationml/2006/main">
+<p:sld xmlns:a="http://schemas.openxmlformats.org/drawingml/2006/main" xmlns:p="http://schemas.openxmlformats.org/presentationml/2006/main" xmlns:r="http://schemas.openxmlformats.org/officeDocument/2006/relationships">
   <p:cSld>
     <p:bg>
       <p:bgPr>
@@ -4619,14 +4575,7 @@
         <p:cNvGrpSpPr/>
         <p:nvPr/>
       </p:nvGrpSpPr>
-      <p:grpSpPr>
-        <a:xfrm>
-          <a:off x="0" y="0"/>
-          <a:ext cx="0" cy="0"/>
-          <a:chOff x="0" y="0"/>
-          <a:chExt cx="0" cy="0"/>
-        </a:xfrm>
-      </p:grpSpPr>
+      <p:grpSpPr/>
       <p:sp>
         <p:nvSpPr>
           <p:cNvPr id="2" name="TextBox 1"/>
@@ -4741,8 +4690,8 @@
         </p:blipFill>
         <p:spPr>
           <a:xfrm>
-            <a:off x="5934456" y="755122"/>
-            <a:ext cx="5724144" cy="5792775"/>
+            <a:off x="502920" y="3200400"/>
+            <a:ext cx="11155680" cy="11289431"/>
           </a:xfrm>
           <a:prstGeom prst="rect">
             <a:avLst/>
@@ -4827,7 +4776,7 @@
 </file>
 
 <file path=ppt/slides/slide17.xml><?xml version="1.0" encoding="utf-8"?>
-<p:sld xmlns:a="http://schemas.openxmlformats.org/drawingml/2006/main" xmlns:r="http://schemas.openxmlformats.org/officeDocument/2006/relationships" xmlns:p="http://schemas.openxmlformats.org/presentationml/2006/main">
+<p:sld xmlns:a="http://schemas.openxmlformats.org/drawingml/2006/main" xmlns:p="http://schemas.openxmlformats.org/presentationml/2006/main" xmlns:r="http://schemas.openxmlformats.org/officeDocument/2006/relationships">
   <p:cSld>
     <p:bg>
       <p:bgPr>
@@ -4843,14 +4792,7 @@
         <p:cNvGrpSpPr/>
         <p:nvPr/>
       </p:nvGrpSpPr>
-      <p:grpSpPr>
-        <a:xfrm>
-          <a:off x="0" y="0"/>
-          <a:ext cx="0" cy="0"/>
-          <a:chOff x="0" y="0"/>
-          <a:chExt cx="0" cy="0"/>
-        </a:xfrm>
-      </p:grpSpPr>
+      <p:grpSpPr/>
       <p:sp>
         <p:nvSpPr>
           <p:cNvPr id="2" name="TextBox 1"/>
@@ -4965,8 +4907,8 @@
         </p:blipFill>
         <p:spPr>
           <a:xfrm>
-            <a:off x="661417" y="2211166"/>
-            <a:ext cx="4523232" cy="4509674"/>
+            <a:off x="502920" y="3200400"/>
+            <a:ext cx="5440679" cy="5424371"/>
           </a:xfrm>
           <a:prstGeom prst="rect">
             <a:avLst/>
@@ -5022,7 +4964,7 @@
         </p:blipFill>
         <p:spPr>
           <a:xfrm>
-            <a:off x="6462272" y="610669"/>
+            <a:off x="6217919" y="3200400"/>
             <a:ext cx="5440679" cy="5424371"/>
           </a:xfrm>
           <a:prstGeom prst="rect">
@@ -5108,7 +5050,7 @@
 </file>
 
 <file path=ppt/slides/slide18.xml><?xml version="1.0" encoding="utf-8"?>
-<p:sld xmlns:a="http://schemas.openxmlformats.org/drawingml/2006/main" xmlns:r="http://schemas.openxmlformats.org/officeDocument/2006/relationships" xmlns:p="http://schemas.openxmlformats.org/presentationml/2006/main">
+<p:sld xmlns:a="http://schemas.openxmlformats.org/drawingml/2006/main" xmlns:p="http://schemas.openxmlformats.org/presentationml/2006/main" xmlns:r="http://schemas.openxmlformats.org/officeDocument/2006/relationships">
   <p:cSld>
     <p:bg>
       <p:bgPr>
@@ -5124,14 +5066,7 @@
         <p:cNvGrpSpPr/>
         <p:nvPr/>
       </p:nvGrpSpPr>
-      <p:grpSpPr>
-        <a:xfrm>
-          <a:off x="0" y="0"/>
-          <a:ext cx="0" cy="0"/>
-          <a:chOff x="0" y="0"/>
-          <a:chExt cx="0" cy="0"/>
-        </a:xfrm>
-      </p:grpSpPr>
+      <p:grpSpPr/>
       <p:sp>
         <p:nvSpPr>
           <p:cNvPr id="2" name="TextBox 1"/>
@@ -5259,8 +5194,8 @@
         </p:blipFill>
         <p:spPr>
           <a:xfrm>
-            <a:off x="1115567" y="2518553"/>
-            <a:ext cx="4215384" cy="4198335"/>
+            <a:off x="502920" y="3200400"/>
+            <a:ext cx="5440679" cy="5418674"/>
           </a:xfrm>
           <a:prstGeom prst="rect">
             <a:avLst/>
@@ -5316,8 +5251,8 @@
         </p:blipFill>
         <p:spPr>
           <a:xfrm>
-            <a:off x="6138825" y="979680"/>
-            <a:ext cx="5950641" cy="5192520"/>
+            <a:off x="6217919" y="3200400"/>
+            <a:ext cx="5440679" cy="4441439"/>
           </a:xfrm>
           <a:prstGeom prst="rect">
             <a:avLst/>
@@ -5402,7 +5337,7 @@
 </file>
 
 <file path=ppt/slides/slide19.xml><?xml version="1.0" encoding="utf-8"?>
-<p:sld xmlns:a="http://schemas.openxmlformats.org/drawingml/2006/main" xmlns:r="http://schemas.openxmlformats.org/officeDocument/2006/relationships" xmlns:p="http://schemas.openxmlformats.org/presentationml/2006/main">
+<p:sld xmlns:a="http://schemas.openxmlformats.org/drawingml/2006/main" xmlns:p="http://schemas.openxmlformats.org/presentationml/2006/main" xmlns:r="http://schemas.openxmlformats.org/officeDocument/2006/relationships">
   <p:cSld>
     <p:bg>
       <p:bgPr>
@@ -5418,14 +5353,7 @@
         <p:cNvGrpSpPr/>
         <p:nvPr/>
       </p:nvGrpSpPr>
-      <p:grpSpPr>
-        <a:xfrm>
-          <a:off x="0" y="0"/>
-          <a:ext cx="0" cy="0"/>
-          <a:chOff x="0" y="0"/>
-          <a:chExt cx="0" cy="0"/>
-        </a:xfrm>
-      </p:grpSpPr>
+      <p:grpSpPr/>
       <p:sp>
         <p:nvSpPr>
           <p:cNvPr id="2" name="TextBox 1"/>
@@ -5683,7 +5611,7 @@
 </file>
 
 <file path=ppt/slides/slide2.xml><?xml version="1.0" encoding="utf-8"?>
-<p:sld xmlns:a="http://schemas.openxmlformats.org/drawingml/2006/main" xmlns:r="http://schemas.openxmlformats.org/officeDocument/2006/relationships" xmlns:p="http://schemas.openxmlformats.org/presentationml/2006/main">
+<p:sld xmlns:a="http://schemas.openxmlformats.org/drawingml/2006/main" xmlns:p="http://schemas.openxmlformats.org/presentationml/2006/main" xmlns:r="http://schemas.openxmlformats.org/officeDocument/2006/relationships">
   <p:cSld>
     <p:bg>
       <p:bgPr>
@@ -5699,14 +5627,7 @@
         <p:cNvGrpSpPr/>
         <p:nvPr/>
       </p:nvGrpSpPr>
-      <p:grpSpPr>
-        <a:xfrm>
-          <a:off x="0" y="0"/>
-          <a:ext cx="0" cy="0"/>
-          <a:chOff x="0" y="0"/>
-          <a:chExt cx="0" cy="0"/>
-        </a:xfrm>
-      </p:grpSpPr>
+      <p:grpSpPr/>
       <p:sp>
         <p:nvSpPr>
           <p:cNvPr id="2" name="TextBox 1"/>
@@ -5863,7 +5784,7 @@
 </file>
 
 <file path=ppt/slides/slide20.xml><?xml version="1.0" encoding="utf-8"?>
-<p:sld xmlns:a="http://schemas.openxmlformats.org/drawingml/2006/main" xmlns:r="http://schemas.openxmlformats.org/officeDocument/2006/relationships" xmlns:p="http://schemas.openxmlformats.org/presentationml/2006/main">
+<p:sld xmlns:a="http://schemas.openxmlformats.org/drawingml/2006/main" xmlns:p="http://schemas.openxmlformats.org/presentationml/2006/main" xmlns:r="http://schemas.openxmlformats.org/officeDocument/2006/relationships">
   <p:cSld>
     <p:bg>
       <p:bgPr>
@@ -5879,14 +5800,7 @@
         <p:cNvGrpSpPr/>
         <p:nvPr/>
       </p:nvGrpSpPr>
-      <p:grpSpPr>
-        <a:xfrm>
-          <a:off x="0" y="0"/>
-          <a:ext cx="0" cy="0"/>
-          <a:chOff x="0" y="0"/>
-          <a:chExt cx="0" cy="0"/>
-        </a:xfrm>
-      </p:grpSpPr>
+      <p:grpSpPr/>
       <p:sp>
         <p:nvSpPr>
           <p:cNvPr id="2" name="TextBox 1"/>
@@ -6043,7 +5957,7 @@
 </file>
 
 <file path=ppt/slides/slide21.xml><?xml version="1.0" encoding="utf-8"?>
-<p:sld xmlns:a="http://schemas.openxmlformats.org/drawingml/2006/main" xmlns:r="http://schemas.openxmlformats.org/officeDocument/2006/relationships" xmlns:p="http://schemas.openxmlformats.org/presentationml/2006/main">
+<p:sld xmlns:a="http://schemas.openxmlformats.org/drawingml/2006/main" xmlns:p="http://schemas.openxmlformats.org/presentationml/2006/main" xmlns:r="http://schemas.openxmlformats.org/officeDocument/2006/relationships">
   <p:cSld>
     <p:bg>
       <p:bgPr>
@@ -6059,14 +5973,7 @@
         <p:cNvGrpSpPr/>
         <p:nvPr/>
       </p:nvGrpSpPr>
-      <p:grpSpPr>
-        <a:xfrm>
-          <a:off x="0" y="0"/>
-          <a:ext cx="0" cy="0"/>
-          <a:chOff x="0" y="0"/>
-          <a:chExt cx="0" cy="0"/>
-        </a:xfrm>
-      </p:grpSpPr>
+      <p:grpSpPr/>
       <p:sp>
         <p:nvSpPr>
           <p:cNvPr id="2" name="TextBox 1"/>
@@ -6223,7 +6130,7 @@
 </file>
 
 <file path=ppt/slides/slide22.xml><?xml version="1.0" encoding="utf-8"?>
-<p:sld xmlns:a="http://schemas.openxmlformats.org/drawingml/2006/main" xmlns:r="http://schemas.openxmlformats.org/officeDocument/2006/relationships" xmlns:p="http://schemas.openxmlformats.org/presentationml/2006/main">
+<p:sld xmlns:a="http://schemas.openxmlformats.org/drawingml/2006/main" xmlns:p="http://schemas.openxmlformats.org/presentationml/2006/main" xmlns:r="http://schemas.openxmlformats.org/officeDocument/2006/relationships">
   <p:cSld>
     <p:bg>
       <p:bgPr>
@@ -6239,14 +6146,7 @@
         <p:cNvGrpSpPr/>
         <p:nvPr/>
       </p:nvGrpSpPr>
-      <p:grpSpPr>
-        <a:xfrm>
-          <a:off x="0" y="0"/>
-          <a:ext cx="0" cy="0"/>
-          <a:chOff x="0" y="0"/>
-          <a:chExt cx="0" cy="0"/>
-        </a:xfrm>
-      </p:grpSpPr>
+      <p:grpSpPr/>
       <p:sp>
         <p:nvSpPr>
           <p:cNvPr id="2" name="TextBox 1"/>
@@ -6403,7 +6303,7 @@
 </file>
 
 <file path=ppt/slides/slide23.xml><?xml version="1.0" encoding="utf-8"?>
-<p:sld xmlns:a="http://schemas.openxmlformats.org/drawingml/2006/main" xmlns:r="http://schemas.openxmlformats.org/officeDocument/2006/relationships" xmlns:p="http://schemas.openxmlformats.org/presentationml/2006/main">
+<p:sld xmlns:a="http://schemas.openxmlformats.org/drawingml/2006/main" xmlns:p="http://schemas.openxmlformats.org/presentationml/2006/main" xmlns:r="http://schemas.openxmlformats.org/officeDocument/2006/relationships">
   <p:cSld>
     <p:bg>
       <p:bgPr>
@@ -6419,14 +6319,7 @@
         <p:cNvGrpSpPr/>
         <p:nvPr/>
       </p:nvGrpSpPr>
-      <p:grpSpPr>
-        <a:xfrm>
-          <a:off x="0" y="0"/>
-          <a:ext cx="0" cy="0"/>
-          <a:chOff x="0" y="0"/>
-          <a:chExt cx="0" cy="0"/>
-        </a:xfrm>
-      </p:grpSpPr>
+      <p:grpSpPr/>
       <p:sp>
         <p:nvSpPr>
           <p:cNvPr id="2" name="TextBox 1"/>
@@ -6583,7 +6476,7 @@
 </file>
 
 <file path=ppt/slides/slide24.xml><?xml version="1.0" encoding="utf-8"?>
-<p:sld xmlns:a="http://schemas.openxmlformats.org/drawingml/2006/main" xmlns:r="http://schemas.openxmlformats.org/officeDocument/2006/relationships" xmlns:p="http://schemas.openxmlformats.org/presentationml/2006/main">
+<p:sld xmlns:a="http://schemas.openxmlformats.org/drawingml/2006/main" xmlns:p="http://schemas.openxmlformats.org/presentationml/2006/main" xmlns:r="http://schemas.openxmlformats.org/officeDocument/2006/relationships">
   <p:cSld>
     <p:bg>
       <p:bgPr>
@@ -6599,14 +6492,7 @@
         <p:cNvGrpSpPr/>
         <p:nvPr/>
       </p:nvGrpSpPr>
-      <p:grpSpPr>
-        <a:xfrm>
-          <a:off x="0" y="0"/>
-          <a:ext cx="0" cy="0"/>
-          <a:chOff x="0" y="0"/>
-          <a:chExt cx="0" cy="0"/>
-        </a:xfrm>
-      </p:grpSpPr>
+      <p:grpSpPr/>
       <p:sp>
         <p:nvSpPr>
           <p:cNvPr id="2" name="TextBox 1"/>
@@ -6763,7 +6649,7 @@
 </file>
 
 <file path=ppt/slides/slide3.xml><?xml version="1.0" encoding="utf-8"?>
-<p:sld xmlns:a="http://schemas.openxmlformats.org/drawingml/2006/main" xmlns:r="http://schemas.openxmlformats.org/officeDocument/2006/relationships" xmlns:p="http://schemas.openxmlformats.org/presentationml/2006/main">
+<p:sld xmlns:a="http://schemas.openxmlformats.org/drawingml/2006/main" xmlns:p="http://schemas.openxmlformats.org/presentationml/2006/main" xmlns:r="http://schemas.openxmlformats.org/officeDocument/2006/relationships">
   <p:cSld>
     <p:bg>
       <p:bgPr>
@@ -6779,14 +6665,7 @@
         <p:cNvGrpSpPr/>
         <p:nvPr/>
       </p:nvGrpSpPr>
-      <p:grpSpPr>
-        <a:xfrm>
-          <a:off x="0" y="0"/>
-          <a:ext cx="0" cy="0"/>
-          <a:chOff x="0" y="0"/>
-          <a:chExt cx="0" cy="0"/>
-        </a:xfrm>
-      </p:grpSpPr>
+      <p:grpSpPr/>
       <p:sp>
         <p:nvSpPr>
           <p:cNvPr id="2" name="TextBox 1"/>
@@ -6943,7 +6822,7 @@
 </file>
 
 <file path=ppt/slides/slide4.xml><?xml version="1.0" encoding="utf-8"?>
-<p:sld xmlns:a="http://schemas.openxmlformats.org/drawingml/2006/main" xmlns:r="http://schemas.openxmlformats.org/officeDocument/2006/relationships" xmlns:p="http://schemas.openxmlformats.org/presentationml/2006/main">
+<p:sld xmlns:a="http://schemas.openxmlformats.org/drawingml/2006/main" xmlns:p="http://schemas.openxmlformats.org/presentationml/2006/main" xmlns:r="http://schemas.openxmlformats.org/officeDocument/2006/relationships">
   <p:cSld>
     <p:bg>
       <p:bgPr>
@@ -6959,14 +6838,7 @@
         <p:cNvGrpSpPr/>
         <p:nvPr/>
       </p:nvGrpSpPr>
-      <p:grpSpPr>
-        <a:xfrm>
-          <a:off x="0" y="0"/>
-          <a:ext cx="0" cy="0"/>
-          <a:chOff x="0" y="0"/>
-          <a:chExt cx="0" cy="0"/>
-        </a:xfrm>
-      </p:grpSpPr>
+      <p:grpSpPr/>
       <p:sp>
         <p:nvSpPr>
           <p:cNvPr id="2" name="TextBox 1"/>
@@ -7123,7 +6995,7 @@
 </file>
 
 <file path=ppt/slides/slide5.xml><?xml version="1.0" encoding="utf-8"?>
-<p:sld xmlns:a="http://schemas.openxmlformats.org/drawingml/2006/main" xmlns:r="http://schemas.openxmlformats.org/officeDocument/2006/relationships" xmlns:p="http://schemas.openxmlformats.org/presentationml/2006/main">
+<p:sld xmlns:a="http://schemas.openxmlformats.org/drawingml/2006/main" xmlns:p="http://schemas.openxmlformats.org/presentationml/2006/main" xmlns:r="http://schemas.openxmlformats.org/officeDocument/2006/relationships">
   <p:cSld>
     <p:bg>
       <p:bgPr>
@@ -7139,14 +7011,7 @@
         <p:cNvGrpSpPr/>
         <p:nvPr/>
       </p:nvGrpSpPr>
-      <p:grpSpPr>
-        <a:xfrm>
-          <a:off x="0" y="0"/>
-          <a:ext cx="0" cy="0"/>
-          <a:chOff x="0" y="0"/>
-          <a:chExt cx="0" cy="0"/>
-        </a:xfrm>
-      </p:grpSpPr>
+      <p:grpSpPr/>
       <p:sp>
         <p:nvSpPr>
           <p:cNvPr id="2" name="TextBox 1"/>
@@ -7303,7 +7168,7 @@
 </file>
 
 <file path=ppt/slides/slide6.xml><?xml version="1.0" encoding="utf-8"?>
-<p:sld xmlns:a="http://schemas.openxmlformats.org/drawingml/2006/main" xmlns:r="http://schemas.openxmlformats.org/officeDocument/2006/relationships" xmlns:p="http://schemas.openxmlformats.org/presentationml/2006/main">
+<p:sld xmlns:a="http://schemas.openxmlformats.org/drawingml/2006/main" xmlns:p="http://schemas.openxmlformats.org/presentationml/2006/main" xmlns:r="http://schemas.openxmlformats.org/officeDocument/2006/relationships">
   <p:cSld>
     <p:bg>
       <p:bgPr>
@@ -7319,14 +7184,7 @@
         <p:cNvGrpSpPr/>
         <p:nvPr/>
       </p:nvGrpSpPr>
-      <p:grpSpPr>
-        <a:xfrm>
-          <a:off x="0" y="0"/>
-          <a:ext cx="0" cy="0"/>
-          <a:chOff x="0" y="0"/>
-          <a:chExt cx="0" cy="0"/>
-        </a:xfrm>
-      </p:grpSpPr>
+      <p:grpSpPr/>
       <p:sp>
         <p:nvSpPr>
           <p:cNvPr id="2" name="TextBox 1"/>
@@ -7483,7 +7341,7 @@
 </file>
 
 <file path=ppt/slides/slide7.xml><?xml version="1.0" encoding="utf-8"?>
-<p:sld xmlns:a="http://schemas.openxmlformats.org/drawingml/2006/main" xmlns:r="http://schemas.openxmlformats.org/officeDocument/2006/relationships" xmlns:p="http://schemas.openxmlformats.org/presentationml/2006/main">
+<p:sld xmlns:a="http://schemas.openxmlformats.org/drawingml/2006/main" xmlns:p="http://schemas.openxmlformats.org/presentationml/2006/main" xmlns:r="http://schemas.openxmlformats.org/officeDocument/2006/relationships">
   <p:cSld>
     <p:bg>
       <p:bgPr>
@@ -7499,14 +7357,7 @@
         <p:cNvGrpSpPr/>
         <p:nvPr/>
       </p:nvGrpSpPr>
-      <p:grpSpPr>
-        <a:xfrm>
-          <a:off x="0" y="0"/>
-          <a:ext cx="0" cy="0"/>
-          <a:chOff x="0" y="0"/>
-          <a:chExt cx="0" cy="0"/>
-        </a:xfrm>
-      </p:grpSpPr>
+      <p:grpSpPr/>
       <p:sp>
         <p:nvSpPr>
           <p:cNvPr id="2" name="TextBox 1"/>
@@ -7663,7 +7514,7 @@
 </file>
 
 <file path=ppt/slides/slide8.xml><?xml version="1.0" encoding="utf-8"?>
-<p:sld xmlns:a="http://schemas.openxmlformats.org/drawingml/2006/main" xmlns:r="http://schemas.openxmlformats.org/officeDocument/2006/relationships" xmlns:p="http://schemas.openxmlformats.org/presentationml/2006/main">
+<p:sld xmlns:a="http://schemas.openxmlformats.org/drawingml/2006/main" xmlns:p="http://schemas.openxmlformats.org/presentationml/2006/main" xmlns:r="http://schemas.openxmlformats.org/officeDocument/2006/relationships">
   <p:cSld>
     <p:bg>
       <p:bgPr>
@@ -7679,14 +7530,7 @@
         <p:cNvGrpSpPr/>
         <p:nvPr/>
       </p:nvGrpSpPr>
-      <p:grpSpPr>
-        <a:xfrm>
-          <a:off x="0" y="0"/>
-          <a:ext cx="0" cy="0"/>
-          <a:chOff x="0" y="0"/>
-          <a:chExt cx="0" cy="0"/>
-        </a:xfrm>
-      </p:grpSpPr>
+      <p:grpSpPr/>
       <p:sp>
         <p:nvSpPr>
           <p:cNvPr id="2" name="TextBox 1"/>
@@ -7843,7 +7687,7 @@
 </file>
 
 <file path=ppt/slides/slide9.xml><?xml version="1.0" encoding="utf-8"?>
-<p:sld xmlns:a="http://schemas.openxmlformats.org/drawingml/2006/main" xmlns:r="http://schemas.openxmlformats.org/officeDocument/2006/relationships" xmlns:p="http://schemas.openxmlformats.org/presentationml/2006/main">
+<p:sld xmlns:a="http://schemas.openxmlformats.org/drawingml/2006/main" xmlns:p="http://schemas.openxmlformats.org/presentationml/2006/main" xmlns:r="http://schemas.openxmlformats.org/officeDocument/2006/relationships">
   <p:cSld>
     <p:bg>
       <p:bgPr>
@@ -7859,14 +7703,7 @@
         <p:cNvGrpSpPr/>
         <p:nvPr/>
       </p:nvGrpSpPr>
-      <p:grpSpPr>
-        <a:xfrm>
-          <a:off x="0" y="0"/>
-          <a:ext cx="0" cy="0"/>
-          <a:chOff x="0" y="0"/>
-          <a:chExt cx="0" cy="0"/>
-        </a:xfrm>
-      </p:grpSpPr>
+      <p:grpSpPr/>
       <p:sp>
         <p:nvSpPr>
           <p:cNvPr id="2" name="TextBox 1"/>

</xml_diff>